<commit_message>
Cursor: Apply local changes for cloud agent
</commit_message>
<xml_diff>
--- a/docs/自動產稿機器人_產品簡報.pptx
+++ b/docs/自動產稿機器人_產品簡報.pptx
@@ -3241,8 +3241,8 @@
                 </a:solidFill>
                 <a:latin typeface="Microsoft JhengHei"/>
               </a:rPr>
-              <a:t>自動產稿機器人｜新聞／參考口播 → IG・FB 約 30 秒、高留言導向六欄稿。
-台灣繁中、結構保底、規則可自定。</a:t>
+              <a:t>自動產稿機器人｜新聞／參考口播／影片轉錄 → IG・FB 約 30 秒、高留言導向六欄稿。
+台灣繁中、結構保底、規則可自定；可加值串接轉錄機器人。</a:t>
             </a:r>
           </a:p>
         </p:txBody>
@@ -3806,7 +3806,7 @@
                 </a:solidFill>
                 <a:latin typeface="Microsoft JhengHei"/>
               </a:rPr>
-              <a:t>3｜換人口吻就飄</a:t>
+              <a:t>3｜下一篇就感覺哪裡都不對</a:t>
             </a:r>
           </a:p>
         </p:txBody>
@@ -4067,13 +4067,13 @@
           <a:p>
             <a:pPr algn="l"/>
             <a:r>
-              <a:rPr sz="3200" b="1">
+              <a:rPr sz="2800" b="1">
                 <a:solidFill>
                   <a:srgbClr val="0B1F3A"/>
                 </a:solidFill>
                 <a:latin typeface="Microsoft JhengHei"/>
               </a:rPr>
-              <a:t>把「參考稿／題材」變成可上架口播包</a:t>
+              <a:t>把「參考稿／題材／影片」變成可上架口播包</a:t>
             </a:r>
           </a:p>
         </p:txBody>
@@ -4198,6 +4198,17 @@
                 </a:solidFill>
                 <a:latin typeface="Microsoft JhengHei"/>
               </a:rPr>
+              <a:t>也可：影片網址 → 轉錄文字 → 貼回產稿</a:t>
+            </a:r>
+          </a:p>
+          <a:p>
+            <a:r>
+              <a:rPr sz="1300" b="0">
+                <a:solidFill>
+                  <a:srgbClr val="5B6B7C"/>
+                </a:solidFill>
+                <a:latin typeface="Microsoft JhengHei"/>
+              </a:rPr>
               <a:t/>
             </a:r>
           </a:p>
@@ -4367,7 +4378,7 @@
                 </a:solidFill>
                 <a:latin typeface="Microsoft JhengHei"/>
               </a:rPr>
-              <a:t>繁中台灣白話｜禁陸網用語</a:t>
+              <a:t>一鍵複製可贴 Google Sheet</a:t>
             </a:r>
           </a:p>
           <a:p>
@@ -4378,7 +4389,7 @@
                 </a:solidFill>
                 <a:latin typeface="Microsoft JhengHei"/>
               </a:rPr>
-              <a:t>一鍵複製可贴 Google Sheet</a:t>
+              <a:t>轉錄機器人餵文字進來</a:t>
             </a:r>
           </a:p>
         </p:txBody>
@@ -4714,7 +4725,7 @@
                 </a:solidFill>
                 <a:latin typeface="Microsoft JhengHei"/>
               </a:rPr>
-              <a:t>貼新聞／參考口播／舊稿</a:t>
+              <a:t>貼新聞／參考口播／舊稿／轉錄文字</a:t>
             </a:r>
           </a:p>
           <a:p>
@@ -5707,13 +5718,13 @@
           <a:p>
             <a:pPr algn="l"/>
             <a:r>
-              <a:rPr sz="3000" b="1">
+              <a:rPr sz="2800" b="1">
                 <a:solidFill>
                   <a:srgbClr val="0B1F3A"/>
                 </a:solidFill>
                 <a:latin typeface="Microsoft JhengHei"/>
               </a:rPr>
-              <a:t>空白跟系統預設　有填才改那一塊</a:t>
+              <a:t>系統預設與客製化　留白沿用｜有填才改那一塊</a:t>
             </a:r>
           </a:p>
         </p:txBody>
@@ -5849,7 +5860,7 @@
                 </a:solidFill>
                 <a:latin typeface="Microsoft JhengHei"/>
               </a:rPr>
-              <a:t>要／不要｜標準文案範例</a:t>
+              <a:t>要／不要｜口播文案參考區</a:t>
             </a:r>
           </a:p>
           <a:p>
@@ -6216,7 +6227,7 @@
                 </a:solidFill>
                 <a:latin typeface="Microsoft JhengHei"/>
               </a:rPr>
-              <a:t>上手只要三步</a:t>
+              <a:t>上手一條龍</a:t>
             </a:r>
           </a:p>
         </p:txBody>
@@ -6245,13 +6256,13 @@
           <a:p>
             <a:pPr algn="l"/>
             <a:r>
-              <a:rPr sz="3400" b="1">
+              <a:rPr sz="3000" b="1">
                 <a:solidFill>
                   <a:srgbClr val="0B1F3A"/>
                 </a:solidFill>
                 <a:latin typeface="Microsoft JhengHei"/>
               </a:rPr>
-              <a:t>今天就能開始產</a:t>
+              <a:t>打開網址就能產　有影片就先轉錄</a:t>
             </a:r>
           </a:p>
         </p:txBody>
@@ -6264,8 +6275,8 @@
         </p:nvSpPr>
         <p:spPr>
           <a:xfrm>
-            <a:off x="640080" y="2011680"/>
-            <a:ext cx="3383280" cy="3017520"/>
+            <a:off x="502920" y="2011680"/>
+            <a:ext cx="2651760" cy="3017520"/>
           </a:xfrm>
           <a:prstGeom prst="roundRect">
             <a:avLst>
@@ -6309,8 +6320,8 @@
         </p:nvSpPr>
         <p:spPr>
           <a:xfrm>
-            <a:off x="841248" y="2194560"/>
-            <a:ext cx="3017520" cy="365760"/>
+            <a:off x="704088" y="2194560"/>
+            <a:ext cx="2286000" cy="365760"/>
           </a:xfrm>
           <a:prstGeom prst="rect">
             <a:avLst/>
@@ -6331,7 +6342,7 @@
                 </a:solidFill>
                 <a:latin typeface="Microsoft JhengHei"/>
               </a:rPr>
-              <a:t>1｜打開專屬網址</a:t>
+              <a:t>1｜打開產稿網址</a:t>
             </a:r>
           </a:p>
         </p:txBody>
@@ -6344,8 +6355,8 @@
         </p:nvSpPr>
         <p:spPr>
           <a:xfrm>
-            <a:off x="841248" y="2606040"/>
-            <a:ext cx="3017520" cy="2240280"/>
+            <a:off x="704088" y="2606040"/>
+            <a:ext cx="2286000" cy="2240280"/>
           </a:xfrm>
           <a:prstGeom prst="rect">
             <a:avLst/>
@@ -6365,7 +6376,7 @@
                 </a:solidFill>
                 <a:latin typeface="Microsoft JhengHei"/>
               </a:rPr>
-              <a:t>登入後進入產稿工作台</a:t>
+              <a:t>進入工作台</a:t>
             </a:r>
           </a:p>
           <a:p>
@@ -6376,7 +6387,7 @@
                 </a:solidFill>
                 <a:latin typeface="Microsoft JhengHei"/>
               </a:rPr>
-              <a:t>不用安裝、不用設環境</a:t>
+              <a:t>不用安裝</a:t>
             </a:r>
           </a:p>
         </p:txBody>
@@ -6389,8 +6400,8 @@
         </p:nvSpPr>
         <p:spPr>
           <a:xfrm>
-            <a:off x="4297680" y="2011680"/>
-            <a:ext cx="3383280" cy="3017520"/>
+            <a:off x="3337560" y="2011680"/>
+            <a:ext cx="2651760" cy="3017520"/>
           </a:xfrm>
           <a:prstGeom prst="roundRect">
             <a:avLst>
@@ -6434,8 +6445,8 @@
         </p:nvSpPr>
         <p:spPr>
           <a:xfrm>
-            <a:off x="4498848" y="2194560"/>
-            <a:ext cx="3017520" cy="365760"/>
+            <a:off x="3538728" y="2194560"/>
+            <a:ext cx="2286000" cy="365760"/>
           </a:xfrm>
           <a:prstGeom prst="rect">
             <a:avLst/>
@@ -6456,7 +6467,7 @@
                 </a:solidFill>
                 <a:latin typeface="Microsoft JhengHei"/>
               </a:rPr>
-              <a:t>2｜自定義規則（可選）</a:t>
+              <a:t>2｜規則（可選）</a:t>
             </a:r>
           </a:p>
         </p:txBody>
@@ -6469,8 +6480,8 @@
         </p:nvSpPr>
         <p:spPr>
           <a:xfrm>
-            <a:off x="4498848" y="2606040"/>
-            <a:ext cx="3017520" cy="2240280"/>
+            <a:off x="3538728" y="2606040"/>
+            <a:ext cx="2286000" cy="2240280"/>
           </a:xfrm>
           <a:prstGeom prst="rect">
             <a:avLst/>
@@ -6514,8 +6525,8 @@
         </p:nvSpPr>
         <p:spPr>
           <a:xfrm>
-            <a:off x="7955279" y="2011680"/>
-            <a:ext cx="3383280" cy="3017520"/>
+            <a:off x="6172200" y="2011680"/>
+            <a:ext cx="2651760" cy="3017520"/>
           </a:xfrm>
           <a:prstGeom prst="roundRect">
             <a:avLst>
@@ -6559,8 +6570,8 @@
         </p:nvSpPr>
         <p:spPr>
           <a:xfrm>
-            <a:off x="8156447" y="2194560"/>
-            <a:ext cx="3017520" cy="365760"/>
+            <a:off x="6373368" y="2194560"/>
+            <a:ext cx="2286000" cy="365760"/>
           </a:xfrm>
           <a:prstGeom prst="rect">
             <a:avLst/>
@@ -6581,7 +6592,7 @@
                 </a:solidFill>
                 <a:latin typeface="Microsoft JhengHei"/>
               </a:rPr>
-              <a:t>3｜貼稿或丟題材</a:t>
+              <a:t>3｜影片丟轉錄（可選）</a:t>
             </a:r>
           </a:p>
         </p:txBody>
@@ -6594,8 +6605,8 @@
         </p:nvSpPr>
         <p:spPr>
           <a:xfrm>
-            <a:off x="8156447" y="2606040"/>
-            <a:ext cx="3017520" cy="2240280"/>
+            <a:off x="6373368" y="2606040"/>
+            <a:ext cx="2286000" cy="2240280"/>
           </a:xfrm>
           <a:prstGeom prst="rect">
             <a:avLst/>
@@ -6615,7 +6626,7 @@
                 </a:solidFill>
                 <a:latin typeface="Microsoft JhengHei"/>
               </a:rPr>
-              <a:t>選角度 → 開始產稿</a:t>
+              <a:t>網址進轉錄機器人</a:t>
             </a:r>
           </a:p>
           <a:p>
@@ -6626,7 +6637,7 @@
                 </a:solidFill>
                 <a:latin typeface="Microsoft JhengHei"/>
               </a:rPr>
-              <a:t>分欄複製或貼 Sheet</a:t>
+              <a:t>複製文字</a:t>
             </a:r>
           </a:p>
         </p:txBody>
@@ -6639,8 +6650,8 @@
         </p:nvSpPr>
         <p:spPr>
           <a:xfrm>
-            <a:off x="411480" y="5989320"/>
-            <a:ext cx="11338560" cy="594360"/>
+            <a:off x="9006840" y="2011680"/>
+            <a:ext cx="2651760" cy="3017520"/>
           </a:xfrm>
           <a:prstGeom prst="roundRect">
             <a:avLst>
@@ -6669,6 +6680,131 @@
           </a:fontRef>
         </p:style>
         <p:txBody>
+          <a:bodyPr rtlCol="0" anchor="ctr"/>
+          <a:lstStyle/>
+          <a:p>
+            <a:pPr algn="ctr"/>
+          </a:p>
+        </p:txBody>
+      </p:sp>
+      <p:sp>
+        <p:nvSpPr>
+          <p:cNvPr id="15" name="TextBox 14"/>
+          <p:cNvSpPr txBox="1"/>
+          <p:nvPr/>
+        </p:nvSpPr>
+        <p:spPr>
+          <a:xfrm>
+            <a:off x="9208008" y="2194560"/>
+            <a:ext cx="2286000" cy="365760"/>
+          </a:xfrm>
+          <a:prstGeom prst="rect">
+            <a:avLst/>
+          </a:prstGeom>
+          <a:noFill/>
+        </p:spPr>
+        <p:txBody>
+          <a:bodyPr wrap="square">
+            <a:spAutoFit/>
+          </a:bodyPr>
+          <a:lstStyle/>
+          <a:p>
+            <a:pPr algn="l"/>
+            <a:r>
+              <a:rPr sz="1800" b="1">
+                <a:solidFill>
+                  <a:srgbClr val="FFFFFF"/>
+                </a:solidFill>
+                <a:latin typeface="Microsoft JhengHei"/>
+              </a:rPr>
+              <a:t>4｜貼上就產六欄</a:t>
+            </a:r>
+          </a:p>
+        </p:txBody>
+      </p:sp>
+      <p:sp>
+        <p:nvSpPr>
+          <p:cNvPr id="16" name="TextBox 15"/>
+          <p:cNvSpPr txBox="1"/>
+          <p:nvPr/>
+        </p:nvSpPr>
+        <p:spPr>
+          <a:xfrm>
+            <a:off x="9208008" y="2606040"/>
+            <a:ext cx="2286000" cy="2240280"/>
+          </a:xfrm>
+          <a:prstGeom prst="rect">
+            <a:avLst/>
+          </a:prstGeom>
+          <a:noFill/>
+        </p:spPr>
+        <p:txBody>
+          <a:bodyPr wrap="square">
+            <a:spAutoFit/>
+          </a:bodyPr>
+          <a:lstStyle/>
+          <a:p>
+            <a:r>
+              <a:rPr sz="1300" b="0">
+                <a:solidFill>
+                  <a:srgbClr val="C9E6D4"/>
+                </a:solidFill>
+                <a:latin typeface="Microsoft JhengHei"/>
+              </a:rPr>
+              <a:t>貼稿／轉錄／題材</a:t>
+            </a:r>
+          </a:p>
+          <a:p>
+            <a:r>
+              <a:rPr sz="1300" b="0">
+                <a:solidFill>
+                  <a:srgbClr val="C9E6D4"/>
+                </a:solidFill>
+                <a:latin typeface="Microsoft JhengHei"/>
+              </a:rPr>
+              <a:t>選角度 → 貼 Sheet</a:t>
+            </a:r>
+          </a:p>
+        </p:txBody>
+      </p:sp>
+      <p:sp>
+        <p:nvSpPr>
+          <p:cNvPr id="17" name="Rounded Rectangle 16"/>
+          <p:cNvSpPr/>
+          <p:nvPr/>
+        </p:nvSpPr>
+        <p:spPr>
+          <a:xfrm>
+            <a:off x="411480" y="5989320"/>
+            <a:ext cx="11338560" cy="594360"/>
+          </a:xfrm>
+          <a:prstGeom prst="roundRect">
+            <a:avLst>
+              <a:gd name="adj" fmla="val 15000"/>
+            </a:avLst>
+          </a:prstGeom>
+          <a:solidFill>
+            <a:srgbClr val="0B1F3A"/>
+          </a:solidFill>
+          <a:ln>
+            <a:noFill/>
+          </a:ln>
+        </p:spPr>
+        <p:style>
+          <a:lnRef idx="1">
+            <a:schemeClr val="accent1"/>
+          </a:lnRef>
+          <a:fillRef idx="3">
+            <a:schemeClr val="accent1"/>
+          </a:fillRef>
+          <a:effectRef idx="2">
+            <a:schemeClr val="accent1"/>
+          </a:effectRef>
+          <a:fontRef idx="minor">
+            <a:schemeClr val="lt1"/>
+          </a:fontRef>
+        </p:style>
+        <p:txBody>
           <a:bodyPr rtlCol="0" anchor="ctr" wrap="square"/>
           <a:lstStyle/>
           <a:p>
@@ -6680,14 +6816,14 @@
                 </a:solidFill>
                 <a:latin typeface="Microsoft JhengHei"/>
               </a:rPr>
-              <a:t>  結果句：未來你只會拿到一串網址——進去就能完成整套產稿。</a:t>
-            </a:r>
-          </a:p>
-        </p:txBody>
-      </p:sp>
-      <p:sp>
-        <p:nvSpPr>
-          <p:cNvPr id="15" name="TextBox 14"/>
+              <a:t>  結果句：丟網址、貼文字、出稿——打開就能用。</a:t>
+            </a:r>
+          </a:p>
+        </p:txBody>
+      </p:sp>
+      <p:sp>
+        <p:nvSpPr>
+          <p:cNvPr id="18" name="TextBox 17"/>
           <p:cNvSpPr txBox="1"/>
           <p:nvPr/>
         </p:nvSpPr>
@@ -7075,7 +7211,7 @@
                 </a:solidFill>
                 <a:latin typeface="Microsoft JhengHei"/>
               </a:rPr>
-              <a:t>可擴</a:t>
+              <a:t>含轉錄</a:t>
             </a:r>
           </a:p>
         </p:txBody>
@@ -7109,7 +7245,7 @@
                 </a:solidFill>
                 <a:latin typeface="Microsoft JhengHei"/>
               </a:rPr>
-              <a:t>多帳號切換</a:t>
+              <a:t>影片網址→文字</a:t>
             </a:r>
           </a:p>
           <a:p>
@@ -7120,18 +7256,7 @@
                 </a:solidFill>
                 <a:latin typeface="Microsoft JhengHei"/>
               </a:rPr>
-              <a:t>產稿歷史</a:t>
-            </a:r>
-          </a:p>
-          <a:p>
-            <a:r>
-              <a:rPr sz="1300" b="0">
-                <a:solidFill>
-                  <a:srgbClr val="5B6B7C"/>
-                </a:solidFill>
-                <a:latin typeface="Microsoft JhengHei"/>
-              </a:rPr>
-              <a:t>規則雲端同步</a:t>
+              <a:t>再餵進產稿</a:t>
             </a:r>
           </a:p>
         </p:txBody>
@@ -7245,7 +7370,7 @@
                 </a:solidFill>
                 <a:latin typeface="Microsoft JhengHei"/>
               </a:rPr>
-              <a:t>團隊權限</a:t>
+              <a:t>多帳號／歷史</a:t>
             </a:r>
           </a:p>
           <a:p>
@@ -7256,18 +7381,7 @@
                 </a:solidFill>
                 <a:latin typeface="Microsoft JhengHei"/>
               </a:rPr>
-              <a:t>用量控管</a:t>
-            </a:r>
-          </a:p>
-          <a:p>
-            <a:r>
-              <a:rPr sz="1300" b="0">
-                <a:solidFill>
-                  <a:srgbClr val="5B6B7C"/>
-                </a:solidFill>
-                <a:latin typeface="Microsoft JhengHei"/>
-              </a:rPr>
-              <a:t>品牌版型</a:t>
+              <a:t>規則雲端同步</a:t>
             </a:r>
           </a:p>
         </p:txBody>

</xml_diff>